<commit_message>
feat(presentation): add "Take it with you" scan-to-explore QR slide
Left QR -> the cpp-concurrency-and-parallelism site, right QR -> the Workshops &
Tutorials hub. Appended to the committed pptx (python-pptx-built decks).
</commit_message>
<xml_diff>
--- a/presentation/cpp-concurrency-100-mental-model.pptx
+++ b/presentation/cpp-concurrency-100-mental-model.pptx
@@ -41,6 +41,7 @@
     <p:sldId id="289" r:id="rId41"/>
     <p:sldId id="290" r:id="rId42"/>
     <p:sldId id="291" r:id="rId43"/>
+    <p:sldId id="292" r:id="rId44"/>
   </p:sldIdLst>
   <p:sldSz cx="12191695" cy="6858000" type="screen4x3"/>
   <p:notesSz cx="6858000" cy="9144000"/>
@@ -17162,6 +17163,428 @@
           </a:p>
         </p:txBody>
       </p:sp>
+    </p:spTree>
+  </p:cSld>
+  <p:clrMapOvr>
+    <a:masterClrMapping/>
+  </p:clrMapOvr>
+</p:sld>
+</file>
+
+<file path=ppt/slides/slide37.xml><?xml version="1.0" encoding="utf-8"?>
+<p:sld xmlns:a="http://schemas.openxmlformats.org/drawingml/2006/main" xmlns:p="http://schemas.openxmlformats.org/presentationml/2006/main" xmlns:r="http://schemas.openxmlformats.org/officeDocument/2006/relationships">
+  <p:bg>
+    <p:bgPr>
+      <a:solidFill>
+        <a:srgbClr val="FFFFFF"/>
+      </a:solidFill>
+      <a:effectLst/>
+    </p:bgPr>
+  </p:bg>
+  <p:cSld>
+    <p:spTree>
+      <p:nvGrpSpPr>
+        <p:cNvPr id="1" name=""/>
+        <p:cNvGrpSpPr/>
+        <p:nvPr/>
+      </p:nvGrpSpPr>
+      <p:grpSpPr/>
+      <p:sp>
+        <p:nvSpPr>
+          <p:cNvPr id="2" name="TextBox 1"/>
+          <p:cNvSpPr txBox="1"/>
+          <p:nvPr/>
+        </p:nvSpPr>
+        <p:spPr>
+          <a:xfrm>
+            <a:off x="566927" y="384047"/>
+            <a:ext cx="11055095" cy="292607"/>
+          </a:xfrm>
+          <a:prstGeom prst="rect">
+            <a:avLst/>
+          </a:prstGeom>
+          <a:noFill/>
+        </p:spPr>
+        <p:txBody>
+          <a:bodyPr wrap="square" lIns="0" rIns="0" tIns="0" bIns="0" anchor="ctr">
+            <a:spAutoFit/>
+          </a:bodyPr>
+          <a:lstStyle/>
+          <a:p>
+            <a:pPr algn="l"/>
+            <a:r>
+              <a:rPr sz="1199" b="1" i="0" spc="399">
+                <a:solidFill>
+                  <a:srgbClr val="EE0000"/>
+                </a:solidFill>
+                <a:latin typeface="Overpass"/>
+                <a:cs typeface="Overpass"/>
+              </a:rPr>
+              <a:t>SCAN TO EXPLORE</a:t>
+            </a:r>
+          </a:p>
+        </p:txBody>
+      </p:sp>
+      <p:sp>
+        <p:nvSpPr>
+          <p:cNvPr id="3" name="TextBox 2"/>
+          <p:cNvSpPr txBox="1"/>
+          <p:nvPr/>
+        </p:nvSpPr>
+        <p:spPr>
+          <a:xfrm>
+            <a:off x="566927" y="676655"/>
+            <a:ext cx="11055095" cy="1005839"/>
+          </a:xfrm>
+          <a:prstGeom prst="rect">
+            <a:avLst/>
+          </a:prstGeom>
+          <a:noFill/>
+        </p:spPr>
+        <p:txBody>
+          <a:bodyPr wrap="square" lIns="0" rIns="0" tIns="0" bIns="0" anchor="t">
+            <a:spAutoFit/>
+          </a:bodyPr>
+          <a:lstStyle/>
+          <a:p>
+            <a:pPr algn="l"/>
+            <a:r>
+              <a:rPr sz="2999" b="1" i="0">
+                <a:solidFill>
+                  <a:srgbClr val="151515"/>
+                </a:solidFill>
+                <a:latin typeface="Overpass"/>
+                <a:cs typeface="Overpass"/>
+              </a:rPr>
+              <a:t>Take it with you</a:t>
+            </a:r>
+          </a:p>
+        </p:txBody>
+      </p:sp>
+      <p:pic>
+        <p:nvPicPr>
+          <p:cNvPr id="4" name="Picture 3" descr="qr-cppc-site.png"/>
+          <p:cNvPicPr>
+            <a:picLocks noChangeAspect="1"/>
+          </p:cNvPicPr>
+          <p:nvPr/>
+        </p:nvPicPr>
+        <p:blipFill>
+          <a:blip r:embed="rId2"/>
+          <a:stretch>
+            <a:fillRect/>
+          </a:stretch>
+        </p:blipFill>
+        <p:spPr>
+          <a:xfrm>
+            <a:off x="2103119" y="1627631"/>
+            <a:ext cx="2834639" cy="2834639"/>
+          </a:xfrm>
+          <a:prstGeom prst="rect">
+            <a:avLst/>
+          </a:prstGeom>
+        </p:spPr>
+      </p:pic>
+      <p:sp>
+        <p:nvSpPr>
+          <p:cNvPr id="5" name="TextBox 4"/>
+          <p:cNvSpPr txBox="1"/>
+          <p:nvPr/>
+        </p:nvSpPr>
+        <p:spPr>
+          <a:xfrm>
+            <a:off x="1417319" y="4553711"/>
+            <a:ext cx="4206239" cy="365759"/>
+          </a:xfrm>
+          <a:prstGeom prst="rect">
+            <a:avLst/>
+          </a:prstGeom>
+          <a:noFill/>
+        </p:spPr>
+        <p:txBody>
+          <a:bodyPr wrap="square" lIns="0" rIns="0" tIns="0" bIns="0" anchor="ctr">
+            <a:spAutoFit/>
+          </a:bodyPr>
+          <a:lstStyle/>
+          <a:p>
+            <a:pPr algn="ctr"/>
+            <a:r>
+              <a:rPr sz="1799" b="1" i="0">
+                <a:solidFill>
+                  <a:srgbClr val="151515"/>
+                </a:solidFill>
+                <a:latin typeface="Overpass"/>
+                <a:cs typeface="Overpass"/>
+              </a:rPr>
+              <a:t>The site</a:t>
+            </a:r>
+          </a:p>
+        </p:txBody>
+      </p:sp>
+      <p:sp>
+        <p:nvSpPr>
+          <p:cNvPr id="6" name="TextBox 5"/>
+          <p:cNvSpPr txBox="1"/>
+          <p:nvPr/>
+        </p:nvSpPr>
+        <p:spPr>
+          <a:xfrm>
+            <a:off x="1325879" y="4937759"/>
+            <a:ext cx="4389119" cy="658367"/>
+          </a:xfrm>
+          <a:prstGeom prst="rect">
+            <a:avLst/>
+          </a:prstGeom>
+          <a:noFill/>
+        </p:spPr>
+        <p:txBody>
+          <a:bodyPr wrap="square" lIns="0" rIns="0" tIns="0" bIns="0" anchor="t">
+            <a:spAutoFit/>
+          </a:bodyPr>
+          <a:lstStyle/>
+          <a:p>
+            <a:pPr algn="ctr"/>
+            <a:r>
+              <a:rPr sz="1299" b="0" i="1">
+                <a:solidFill>
+                  <a:srgbClr val="5A5A5A"/>
+                </a:solidFill>
+                <a:latin typeface="Red Hat Text"/>
+                <a:cs typeface="Red Hat Text"/>
+              </a:rPr>
+              <a:t>Chapters, the runnable C++ examples, and the benchmarks</a:t>
+            </a:r>
+          </a:p>
+        </p:txBody>
+      </p:sp>
+      <p:sp>
+        <p:nvSpPr>
+          <p:cNvPr id="7" name="TextBox 6"/>
+          <p:cNvSpPr txBox="1"/>
+          <p:nvPr/>
+        </p:nvSpPr>
+        <p:spPr>
+          <a:xfrm>
+            <a:off x="1325879" y="5596127"/>
+            <a:ext cx="4389119" cy="292607"/>
+          </a:xfrm>
+          <a:prstGeom prst="rect">
+            <a:avLst/>
+          </a:prstGeom>
+          <a:noFill/>
+        </p:spPr>
+        <p:txBody>
+          <a:bodyPr wrap="square" lIns="0" rIns="0" tIns="0" bIns="0" anchor="ctr">
+            <a:spAutoFit/>
+          </a:bodyPr>
+          <a:lstStyle/>
+          <a:p>
+            <a:pPr algn="ctr"/>
+            <a:r>
+              <a:rPr sz="899" b="0" i="0">
+                <a:solidFill>
+                  <a:srgbClr val="EE0000"/>
+                </a:solidFill>
+                <a:latin typeface="Red Hat Mono"/>
+                <a:cs typeface="Red Hat Mono"/>
+              </a:rPr>
+              <a:t>patterncatalyst.github.io/cpp-concurrency-and-parallelism</a:t>
+            </a:r>
+          </a:p>
+        </p:txBody>
+      </p:sp>
+      <p:pic>
+        <p:nvPicPr>
+          <p:cNvPr id="8" name="Picture 7" descr="qr-hub.png"/>
+          <p:cNvPicPr>
+            <a:picLocks noChangeAspect="1"/>
+          </p:cNvPicPr>
+          <p:nvPr/>
+        </p:nvPicPr>
+        <p:blipFill>
+          <a:blip r:embed="rId3"/>
+          <a:stretch>
+            <a:fillRect/>
+          </a:stretch>
+        </p:blipFill>
+        <p:spPr>
+          <a:xfrm>
+            <a:off x="7251191" y="1627631"/>
+            <a:ext cx="2834639" cy="2834639"/>
+          </a:xfrm>
+          <a:prstGeom prst="rect">
+            <a:avLst/>
+          </a:prstGeom>
+        </p:spPr>
+      </p:pic>
+      <p:sp>
+        <p:nvSpPr>
+          <p:cNvPr id="9" name="TextBox 8"/>
+          <p:cNvSpPr txBox="1"/>
+          <p:nvPr/>
+        </p:nvSpPr>
+        <p:spPr>
+          <a:xfrm>
+            <a:off x="6565391" y="4553711"/>
+            <a:ext cx="4206239" cy="365759"/>
+          </a:xfrm>
+          <a:prstGeom prst="rect">
+            <a:avLst/>
+          </a:prstGeom>
+          <a:noFill/>
+        </p:spPr>
+        <p:txBody>
+          <a:bodyPr wrap="square" lIns="0" rIns="0" tIns="0" bIns="0" anchor="ctr">
+            <a:spAutoFit/>
+          </a:bodyPr>
+          <a:lstStyle/>
+          <a:p>
+            <a:pPr algn="ctr"/>
+            <a:r>
+              <a:rPr sz="1799" b="1" i="0">
+                <a:solidFill>
+                  <a:srgbClr val="151515"/>
+                </a:solidFill>
+                <a:latin typeface="Overpass"/>
+                <a:cs typeface="Overpass"/>
+              </a:rPr>
+              <a:t>Workshops &amp; Tutorials</a:t>
+            </a:r>
+          </a:p>
+        </p:txBody>
+      </p:sp>
+      <p:sp>
+        <p:nvSpPr>
+          <p:cNvPr id="10" name="TextBox 9"/>
+          <p:cNvSpPr txBox="1"/>
+          <p:nvPr/>
+        </p:nvSpPr>
+        <p:spPr>
+          <a:xfrm>
+            <a:off x="6473951" y="4937759"/>
+            <a:ext cx="4389119" cy="658367"/>
+          </a:xfrm>
+          <a:prstGeom prst="rect">
+            <a:avLst/>
+          </a:prstGeom>
+          <a:noFill/>
+        </p:spPr>
+        <p:txBody>
+          <a:bodyPr wrap="square" lIns="0" rIns="0" tIns="0" bIns="0" anchor="t">
+            <a:spAutoFit/>
+          </a:bodyPr>
+          <a:lstStyle/>
+          <a:p>
+            <a:pPr algn="ctr"/>
+            <a:r>
+              <a:rPr sz="1299" b="0" i="1">
+                <a:solidFill>
+                  <a:srgbClr val="5A5A5A"/>
+                </a:solidFill>
+                <a:latin typeface="Red Hat Text"/>
+                <a:cs typeface="Red Hat Text"/>
+              </a:rPr>
+              <a:t>The whole series: every workshop, tutorial, and deck in one place</a:t>
+            </a:r>
+          </a:p>
+        </p:txBody>
+      </p:sp>
+      <p:sp>
+        <p:nvSpPr>
+          <p:cNvPr id="11" name="TextBox 10"/>
+          <p:cNvSpPr txBox="1"/>
+          <p:nvPr/>
+        </p:nvSpPr>
+        <p:spPr>
+          <a:xfrm>
+            <a:off x="6473951" y="5596127"/>
+            <a:ext cx="4389119" cy="292607"/>
+          </a:xfrm>
+          <a:prstGeom prst="rect">
+            <a:avLst/>
+          </a:prstGeom>
+          <a:noFill/>
+        </p:spPr>
+        <p:txBody>
+          <a:bodyPr wrap="square" lIns="0" rIns="0" tIns="0" bIns="0" anchor="ctr">
+            <a:spAutoFit/>
+          </a:bodyPr>
+          <a:lstStyle/>
+          <a:p>
+            <a:pPr algn="ctr"/>
+            <a:r>
+              <a:rPr sz="899" b="0" i="0">
+                <a:solidFill>
+                  <a:srgbClr val="EE0000"/>
+                </a:solidFill>
+                <a:latin typeface="Red Hat Mono"/>
+                <a:cs typeface="Red Hat Mono"/>
+              </a:rPr>
+              <a:t>patterncatalyst.github.io/patterncatalyst-workshops-tutorials-list</a:t>
+            </a:r>
+          </a:p>
+        </p:txBody>
+      </p:sp>
+      <p:sp>
+        <p:nvSpPr>
+          <p:cNvPr id="12" name="TextBox 11"/>
+          <p:cNvSpPr txBox="1"/>
+          <p:nvPr/>
+        </p:nvSpPr>
+        <p:spPr>
+          <a:xfrm>
+            <a:off x="566927" y="6364223"/>
+            <a:ext cx="914399" cy="274319"/>
+          </a:xfrm>
+          <a:prstGeom prst="rect">
+            <a:avLst/>
+          </a:prstGeom>
+          <a:noFill/>
+        </p:spPr>
+        <p:txBody>
+          <a:bodyPr wrap="square" lIns="0" rIns="0" tIns="0" bIns="0" anchor="ctr">
+            <a:spAutoFit/>
+          </a:bodyPr>
+          <a:lstStyle/>
+          <a:p>
+            <a:pPr algn="l"/>
+            <a:r>
+              <a:rPr sz="999" b="0" i="0">
+                <a:solidFill>
+                  <a:srgbClr val="8A8A8A"/>
+                </a:solidFill>
+                <a:latin typeface="Red Hat Text"/>
+                <a:cs typeface="Red Hat Text"/>
+              </a:rPr>
+              <a:t>37</a:t>
+            </a:r>
+          </a:p>
+        </p:txBody>
+      </p:sp>
+      <p:pic>
+        <p:nvPicPr>
+          <p:cNvPr id="13" name="Picture 12" descr="logo-candidate-2.png"/>
+          <p:cNvPicPr>
+            <a:picLocks noChangeAspect="1"/>
+          </p:cNvPicPr>
+          <p:nvPr/>
+        </p:nvPicPr>
+        <p:blipFill>
+          <a:blip r:embed="rId4"/>
+          <a:stretch>
+            <a:fillRect/>
+          </a:stretch>
+        </p:blipFill>
+        <p:spPr>
+          <a:xfrm>
+            <a:off x="10561319" y="6355079"/>
+            <a:ext cx="1033271" cy="246887"/>
+          </a:xfrm>
+          <a:prstGeom prst="rect">
+            <a:avLst/>
+          </a:prstGeom>
+        </p:spPr>
+      </p:pic>
     </p:spTree>
   </p:cSld>
   <p:clrMapOvr>

</xml_diff>

<commit_message>
feat(presentation): add "Take it with you" scan-to-explore QR slide (#2)
Left QR -> the cpp-concurrency-and-parallelism site, right QR -> the Workshops &
Tutorials hub. Appended to the committed pptx (python-pptx-built decks).
</commit_message>
<xml_diff>
--- a/presentation/cpp-concurrency-100-mental-model.pptx
+++ b/presentation/cpp-concurrency-100-mental-model.pptx
@@ -41,6 +41,7 @@
     <p:sldId id="289" r:id="rId41"/>
     <p:sldId id="290" r:id="rId42"/>
     <p:sldId id="291" r:id="rId43"/>
+    <p:sldId id="292" r:id="rId44"/>
   </p:sldIdLst>
   <p:sldSz cx="12191695" cy="6858000" type="screen4x3"/>
   <p:notesSz cx="6858000" cy="9144000"/>
@@ -17162,6 +17163,428 @@
           </a:p>
         </p:txBody>
       </p:sp>
+    </p:spTree>
+  </p:cSld>
+  <p:clrMapOvr>
+    <a:masterClrMapping/>
+  </p:clrMapOvr>
+</p:sld>
+</file>
+
+<file path=ppt/slides/slide37.xml><?xml version="1.0" encoding="utf-8"?>
+<p:sld xmlns:a="http://schemas.openxmlformats.org/drawingml/2006/main" xmlns:p="http://schemas.openxmlformats.org/presentationml/2006/main" xmlns:r="http://schemas.openxmlformats.org/officeDocument/2006/relationships">
+  <p:bg>
+    <p:bgPr>
+      <a:solidFill>
+        <a:srgbClr val="FFFFFF"/>
+      </a:solidFill>
+      <a:effectLst/>
+    </p:bgPr>
+  </p:bg>
+  <p:cSld>
+    <p:spTree>
+      <p:nvGrpSpPr>
+        <p:cNvPr id="1" name=""/>
+        <p:cNvGrpSpPr/>
+        <p:nvPr/>
+      </p:nvGrpSpPr>
+      <p:grpSpPr/>
+      <p:sp>
+        <p:nvSpPr>
+          <p:cNvPr id="2" name="TextBox 1"/>
+          <p:cNvSpPr txBox="1"/>
+          <p:nvPr/>
+        </p:nvSpPr>
+        <p:spPr>
+          <a:xfrm>
+            <a:off x="566927" y="384047"/>
+            <a:ext cx="11055095" cy="292607"/>
+          </a:xfrm>
+          <a:prstGeom prst="rect">
+            <a:avLst/>
+          </a:prstGeom>
+          <a:noFill/>
+        </p:spPr>
+        <p:txBody>
+          <a:bodyPr wrap="square" lIns="0" rIns="0" tIns="0" bIns="0" anchor="ctr">
+            <a:spAutoFit/>
+          </a:bodyPr>
+          <a:lstStyle/>
+          <a:p>
+            <a:pPr algn="l"/>
+            <a:r>
+              <a:rPr sz="1199" b="1" i="0" spc="399">
+                <a:solidFill>
+                  <a:srgbClr val="EE0000"/>
+                </a:solidFill>
+                <a:latin typeface="Overpass"/>
+                <a:cs typeface="Overpass"/>
+              </a:rPr>
+              <a:t>SCAN TO EXPLORE</a:t>
+            </a:r>
+          </a:p>
+        </p:txBody>
+      </p:sp>
+      <p:sp>
+        <p:nvSpPr>
+          <p:cNvPr id="3" name="TextBox 2"/>
+          <p:cNvSpPr txBox="1"/>
+          <p:nvPr/>
+        </p:nvSpPr>
+        <p:spPr>
+          <a:xfrm>
+            <a:off x="566927" y="676655"/>
+            <a:ext cx="11055095" cy="1005839"/>
+          </a:xfrm>
+          <a:prstGeom prst="rect">
+            <a:avLst/>
+          </a:prstGeom>
+          <a:noFill/>
+        </p:spPr>
+        <p:txBody>
+          <a:bodyPr wrap="square" lIns="0" rIns="0" tIns="0" bIns="0" anchor="t">
+            <a:spAutoFit/>
+          </a:bodyPr>
+          <a:lstStyle/>
+          <a:p>
+            <a:pPr algn="l"/>
+            <a:r>
+              <a:rPr sz="2999" b="1" i="0">
+                <a:solidFill>
+                  <a:srgbClr val="151515"/>
+                </a:solidFill>
+                <a:latin typeface="Overpass"/>
+                <a:cs typeface="Overpass"/>
+              </a:rPr>
+              <a:t>Take it with you</a:t>
+            </a:r>
+          </a:p>
+        </p:txBody>
+      </p:sp>
+      <p:pic>
+        <p:nvPicPr>
+          <p:cNvPr id="4" name="Picture 3" descr="qr-cppc-site.png"/>
+          <p:cNvPicPr>
+            <a:picLocks noChangeAspect="1"/>
+          </p:cNvPicPr>
+          <p:nvPr/>
+        </p:nvPicPr>
+        <p:blipFill>
+          <a:blip r:embed="rId2"/>
+          <a:stretch>
+            <a:fillRect/>
+          </a:stretch>
+        </p:blipFill>
+        <p:spPr>
+          <a:xfrm>
+            <a:off x="2103119" y="1627631"/>
+            <a:ext cx="2834639" cy="2834639"/>
+          </a:xfrm>
+          <a:prstGeom prst="rect">
+            <a:avLst/>
+          </a:prstGeom>
+        </p:spPr>
+      </p:pic>
+      <p:sp>
+        <p:nvSpPr>
+          <p:cNvPr id="5" name="TextBox 4"/>
+          <p:cNvSpPr txBox="1"/>
+          <p:nvPr/>
+        </p:nvSpPr>
+        <p:spPr>
+          <a:xfrm>
+            <a:off x="1417319" y="4553711"/>
+            <a:ext cx="4206239" cy="365759"/>
+          </a:xfrm>
+          <a:prstGeom prst="rect">
+            <a:avLst/>
+          </a:prstGeom>
+          <a:noFill/>
+        </p:spPr>
+        <p:txBody>
+          <a:bodyPr wrap="square" lIns="0" rIns="0" tIns="0" bIns="0" anchor="ctr">
+            <a:spAutoFit/>
+          </a:bodyPr>
+          <a:lstStyle/>
+          <a:p>
+            <a:pPr algn="ctr"/>
+            <a:r>
+              <a:rPr sz="1799" b="1" i="0">
+                <a:solidFill>
+                  <a:srgbClr val="151515"/>
+                </a:solidFill>
+                <a:latin typeface="Overpass"/>
+                <a:cs typeface="Overpass"/>
+              </a:rPr>
+              <a:t>The site</a:t>
+            </a:r>
+          </a:p>
+        </p:txBody>
+      </p:sp>
+      <p:sp>
+        <p:nvSpPr>
+          <p:cNvPr id="6" name="TextBox 5"/>
+          <p:cNvSpPr txBox="1"/>
+          <p:nvPr/>
+        </p:nvSpPr>
+        <p:spPr>
+          <a:xfrm>
+            <a:off x="1325879" y="4937759"/>
+            <a:ext cx="4389119" cy="658367"/>
+          </a:xfrm>
+          <a:prstGeom prst="rect">
+            <a:avLst/>
+          </a:prstGeom>
+          <a:noFill/>
+        </p:spPr>
+        <p:txBody>
+          <a:bodyPr wrap="square" lIns="0" rIns="0" tIns="0" bIns="0" anchor="t">
+            <a:spAutoFit/>
+          </a:bodyPr>
+          <a:lstStyle/>
+          <a:p>
+            <a:pPr algn="ctr"/>
+            <a:r>
+              <a:rPr sz="1299" b="0" i="1">
+                <a:solidFill>
+                  <a:srgbClr val="5A5A5A"/>
+                </a:solidFill>
+                <a:latin typeface="Red Hat Text"/>
+                <a:cs typeface="Red Hat Text"/>
+              </a:rPr>
+              <a:t>Chapters, the runnable C++ examples, and the benchmarks</a:t>
+            </a:r>
+          </a:p>
+        </p:txBody>
+      </p:sp>
+      <p:sp>
+        <p:nvSpPr>
+          <p:cNvPr id="7" name="TextBox 6"/>
+          <p:cNvSpPr txBox="1"/>
+          <p:nvPr/>
+        </p:nvSpPr>
+        <p:spPr>
+          <a:xfrm>
+            <a:off x="1325879" y="5596127"/>
+            <a:ext cx="4389119" cy="292607"/>
+          </a:xfrm>
+          <a:prstGeom prst="rect">
+            <a:avLst/>
+          </a:prstGeom>
+          <a:noFill/>
+        </p:spPr>
+        <p:txBody>
+          <a:bodyPr wrap="square" lIns="0" rIns="0" tIns="0" bIns="0" anchor="ctr">
+            <a:spAutoFit/>
+          </a:bodyPr>
+          <a:lstStyle/>
+          <a:p>
+            <a:pPr algn="ctr"/>
+            <a:r>
+              <a:rPr sz="899" b="0" i="0">
+                <a:solidFill>
+                  <a:srgbClr val="EE0000"/>
+                </a:solidFill>
+                <a:latin typeface="Red Hat Mono"/>
+                <a:cs typeface="Red Hat Mono"/>
+              </a:rPr>
+              <a:t>patterncatalyst.github.io/cpp-concurrency-and-parallelism</a:t>
+            </a:r>
+          </a:p>
+        </p:txBody>
+      </p:sp>
+      <p:pic>
+        <p:nvPicPr>
+          <p:cNvPr id="8" name="Picture 7" descr="qr-hub.png"/>
+          <p:cNvPicPr>
+            <a:picLocks noChangeAspect="1"/>
+          </p:cNvPicPr>
+          <p:nvPr/>
+        </p:nvPicPr>
+        <p:blipFill>
+          <a:blip r:embed="rId3"/>
+          <a:stretch>
+            <a:fillRect/>
+          </a:stretch>
+        </p:blipFill>
+        <p:spPr>
+          <a:xfrm>
+            <a:off x="7251191" y="1627631"/>
+            <a:ext cx="2834639" cy="2834639"/>
+          </a:xfrm>
+          <a:prstGeom prst="rect">
+            <a:avLst/>
+          </a:prstGeom>
+        </p:spPr>
+      </p:pic>
+      <p:sp>
+        <p:nvSpPr>
+          <p:cNvPr id="9" name="TextBox 8"/>
+          <p:cNvSpPr txBox="1"/>
+          <p:nvPr/>
+        </p:nvSpPr>
+        <p:spPr>
+          <a:xfrm>
+            <a:off x="6565391" y="4553711"/>
+            <a:ext cx="4206239" cy="365759"/>
+          </a:xfrm>
+          <a:prstGeom prst="rect">
+            <a:avLst/>
+          </a:prstGeom>
+          <a:noFill/>
+        </p:spPr>
+        <p:txBody>
+          <a:bodyPr wrap="square" lIns="0" rIns="0" tIns="0" bIns="0" anchor="ctr">
+            <a:spAutoFit/>
+          </a:bodyPr>
+          <a:lstStyle/>
+          <a:p>
+            <a:pPr algn="ctr"/>
+            <a:r>
+              <a:rPr sz="1799" b="1" i="0">
+                <a:solidFill>
+                  <a:srgbClr val="151515"/>
+                </a:solidFill>
+                <a:latin typeface="Overpass"/>
+                <a:cs typeface="Overpass"/>
+              </a:rPr>
+              <a:t>Workshops &amp; Tutorials</a:t>
+            </a:r>
+          </a:p>
+        </p:txBody>
+      </p:sp>
+      <p:sp>
+        <p:nvSpPr>
+          <p:cNvPr id="10" name="TextBox 9"/>
+          <p:cNvSpPr txBox="1"/>
+          <p:nvPr/>
+        </p:nvSpPr>
+        <p:spPr>
+          <a:xfrm>
+            <a:off x="6473951" y="4937759"/>
+            <a:ext cx="4389119" cy="658367"/>
+          </a:xfrm>
+          <a:prstGeom prst="rect">
+            <a:avLst/>
+          </a:prstGeom>
+          <a:noFill/>
+        </p:spPr>
+        <p:txBody>
+          <a:bodyPr wrap="square" lIns="0" rIns="0" tIns="0" bIns="0" anchor="t">
+            <a:spAutoFit/>
+          </a:bodyPr>
+          <a:lstStyle/>
+          <a:p>
+            <a:pPr algn="ctr"/>
+            <a:r>
+              <a:rPr sz="1299" b="0" i="1">
+                <a:solidFill>
+                  <a:srgbClr val="5A5A5A"/>
+                </a:solidFill>
+                <a:latin typeface="Red Hat Text"/>
+                <a:cs typeface="Red Hat Text"/>
+              </a:rPr>
+              <a:t>The whole series: every workshop, tutorial, and deck in one place</a:t>
+            </a:r>
+          </a:p>
+        </p:txBody>
+      </p:sp>
+      <p:sp>
+        <p:nvSpPr>
+          <p:cNvPr id="11" name="TextBox 10"/>
+          <p:cNvSpPr txBox="1"/>
+          <p:nvPr/>
+        </p:nvSpPr>
+        <p:spPr>
+          <a:xfrm>
+            <a:off x="6473951" y="5596127"/>
+            <a:ext cx="4389119" cy="292607"/>
+          </a:xfrm>
+          <a:prstGeom prst="rect">
+            <a:avLst/>
+          </a:prstGeom>
+          <a:noFill/>
+        </p:spPr>
+        <p:txBody>
+          <a:bodyPr wrap="square" lIns="0" rIns="0" tIns="0" bIns="0" anchor="ctr">
+            <a:spAutoFit/>
+          </a:bodyPr>
+          <a:lstStyle/>
+          <a:p>
+            <a:pPr algn="ctr"/>
+            <a:r>
+              <a:rPr sz="899" b="0" i="0">
+                <a:solidFill>
+                  <a:srgbClr val="EE0000"/>
+                </a:solidFill>
+                <a:latin typeface="Red Hat Mono"/>
+                <a:cs typeface="Red Hat Mono"/>
+              </a:rPr>
+              <a:t>patterncatalyst.github.io/patterncatalyst-workshops-tutorials-list</a:t>
+            </a:r>
+          </a:p>
+        </p:txBody>
+      </p:sp>
+      <p:sp>
+        <p:nvSpPr>
+          <p:cNvPr id="12" name="TextBox 11"/>
+          <p:cNvSpPr txBox="1"/>
+          <p:nvPr/>
+        </p:nvSpPr>
+        <p:spPr>
+          <a:xfrm>
+            <a:off x="566927" y="6364223"/>
+            <a:ext cx="914399" cy="274319"/>
+          </a:xfrm>
+          <a:prstGeom prst="rect">
+            <a:avLst/>
+          </a:prstGeom>
+          <a:noFill/>
+        </p:spPr>
+        <p:txBody>
+          <a:bodyPr wrap="square" lIns="0" rIns="0" tIns="0" bIns="0" anchor="ctr">
+            <a:spAutoFit/>
+          </a:bodyPr>
+          <a:lstStyle/>
+          <a:p>
+            <a:pPr algn="l"/>
+            <a:r>
+              <a:rPr sz="999" b="0" i="0">
+                <a:solidFill>
+                  <a:srgbClr val="8A8A8A"/>
+                </a:solidFill>
+                <a:latin typeface="Red Hat Text"/>
+                <a:cs typeface="Red Hat Text"/>
+              </a:rPr>
+              <a:t>37</a:t>
+            </a:r>
+          </a:p>
+        </p:txBody>
+      </p:sp>
+      <p:pic>
+        <p:nvPicPr>
+          <p:cNvPr id="13" name="Picture 12" descr="logo-candidate-2.png"/>
+          <p:cNvPicPr>
+            <a:picLocks noChangeAspect="1"/>
+          </p:cNvPicPr>
+          <p:nvPr/>
+        </p:nvPicPr>
+        <p:blipFill>
+          <a:blip r:embed="rId4"/>
+          <a:stretch>
+            <a:fillRect/>
+          </a:stretch>
+        </p:blipFill>
+        <p:spPr>
+          <a:xfrm>
+            <a:off x="10561319" y="6355079"/>
+            <a:ext cx="1033271" cy="246887"/>
+          </a:xfrm>
+          <a:prstGeom prst="rect">
+            <a:avLst/>
+          </a:prstGeom>
+        </p:spPr>
+      </p:pic>
     </p:spTree>
   </p:cSld>
   <p:clrMapOvr>

</xml_diff>